<commit_message>
Tidy repo root and finalise presentation deck
- Move generate_figures.py into scripts/ so the repo root only
  holds runtime artefacts and submission documents
- Add Slides.md as the editable source for Presentation.pptx
- Replace [Vercel URL] placeholders in slides 1 and 15 with a
  visible 'https://<your-deployment>.vercel.app' marker so the
  team can spot-replace before recording
</commit_message>
<xml_diff>
--- a/Presentation.pptx
+++ b/Presentation.pptx
@@ -4353,7 +4353,7 @@
             </a:pPr>
             <a:r>
               <a:rPr/>
-              <a:t>Demo: [Vercel URL] Thank you.</a:t>
+              <a:t>Demo: https://.vercel.app Thank you.</a:t>
             </a:r>
           </a:p>
         </p:txBody>
@@ -4487,7 +4487,7 @@
             </a:pPr>
             <a:r>
               <a:rPr/>
-              <a:t>Live demo: [Vercel URL]</a:t>
+              <a:t>Live demo: https://.vercel.app</a:t>
             </a:r>
           </a:p>
         </p:txBody>

</xml_diff>